<commit_message>
docs: pptx Aurora → RDS PostgreSQL 텍스트 교체 (Task #11 인프라 변경 반영)
Co-Authored-By: Claude Sonnet 4.6 <noreply@anthropic.com>
</commit_message>
<xml_diff>
--- a/subculture_tracker_presentation.pptx
+++ b/subculture_tracker_presentation.pptx
@@ -2214,7 +2214,7 @@
                 <a:ea typeface="Malgun Gothic" pitchFamily="34" charset="-122"/>
                 <a:cs typeface="Malgun Gothic" pitchFamily="34" charset="-120"/>
               </a:rPr>
-              <a:t>Aurora PostgreSQL</a:t>
+              <a:t>RDS PostgreSQL</a:t>
             </a:r>
             <a:endParaRPr lang="en-US" sz="900" dirty="0"/>
           </a:p>
@@ -6245,7 +6245,7 @@
                 <a:ea typeface="Malgun Gothic" pitchFamily="34" charset="-122"/>
                 <a:cs typeface="Malgun Gothic" pitchFamily="34" charset="-120"/>
               </a:rPr>
-              <a:t>Aurora PostgreSQL</a:t>
+              <a:t>RDS PostgreSQL</a:t>
             </a:r>
             <a:endParaRPr lang="en-US" sz="900" dirty="0"/>
           </a:p>
@@ -6262,7 +6262,7 @@
                 <a:ea typeface="Malgun Gothic" pitchFamily="34" charset="-122"/>
                 <a:cs typeface="Malgun Gothic" pitchFamily="34" charset="-120"/>
               </a:rPr>
-              <a:t>Serverless v2</a:t>
+              <a:t>db.t3.micro</a:t>
             </a:r>
             <a:endParaRPr lang="en-US" sz="900" dirty="0"/>
           </a:p>
@@ -8101,7 +8101,7 @@
                 <a:ea typeface="Malgun Gothic" pitchFamily="34" charset="-122"/>
                 <a:cs typeface="Malgun Gothic" pitchFamily="34" charset="-120"/>
               </a:rPr>
-              <a:t>Aurora PostgreSQL에</a:t>
+              <a:t>RDS PostgreSQL에</a:t>
             </a:r>
             <a:endParaRPr lang="en-US" sz="900" dirty="0"/>
           </a:p>
@@ -10208,7 +10208,7 @@
                 <a:ea typeface="Malgun Gothic" pitchFamily="34" charset="-122"/>
                 <a:cs typeface="Malgun Gothic" pitchFamily="34" charset="-120"/>
               </a:rPr>
-              <a:t>Aurora PostgreSQL Serverless v2</a:t>
+              <a:t>RDS PostgreSQL db.t3.micro</a:t>
             </a:r>
             <a:endParaRPr lang="en-US" sz="850" dirty="0"/>
           </a:p>
@@ -18931,7 +18931,7 @@
                 <a:ea typeface="Malgun Gothic" pitchFamily="34" charset="-122"/>
                 <a:cs typeface="Malgun Gothic" pitchFamily="34" charset="-120"/>
               </a:rPr>
-              <a:t>▸  Aurora PostgreSQL Serverless v2</a:t>
+              <a:t>▸  RDS PostgreSQL db.t3.micro</a:t>
             </a:r>
             <a:endParaRPr lang="en-US" sz="950" dirty="0"/>
           </a:p>

</xml_diff>